<commit_message>
Update 바보 게임 assets and add ZIP slides
Co-Authored-By: Claude Opus 4.6 (1M context) <noreply@anthropic.com>
</commit_message>
<xml_diff>
--- a/public/downloads/games/fool-game/rules.pptx
+++ b/public/downloads/games/fool-game/rules.pptx
@@ -14,16 +14,8 @@
   <p:notesSz cx="6858000" cy="9144000"/>
   <p:embeddedFontLst>
     <p:embeddedFont>
-      <p:font typeface="Jua" charset="1" panose="00000000000000000000"/>
+      <p:font typeface="무궁화 고딕" charset="1" panose="02020603020101020101"/>
       <p:regular r:id="rId10"/>
-    </p:embeddedFont>
-    <p:embeddedFont>
-      <p:font typeface="TDTD갬성명조" charset="1" panose="02000503000000000000"/>
-      <p:regular r:id="rId11"/>
-    </p:embeddedFont>
-    <p:embeddedFont>
-      <p:font typeface="TDTD가온" charset="1" panose="02000503000000000000"/>
-      <p:regular r:id="rId12"/>
     </p:embeddedFont>
   </p:embeddedFontLst>
   <p:defaultTextStyle>
@@ -3141,8 +3133,8 @@
         </p:nvSpPr>
         <p:spPr>
           <a:xfrm rot="0">
-            <a:off x="1028700" y="3892867"/>
-            <a:ext cx="15555091" cy="2200275"/>
+            <a:off x="1028700" y="4178617"/>
+            <a:ext cx="15555091" cy="1914525"/>
           </a:xfrm>
           <a:prstGeom prst="rect">
             <a:avLst/>
@@ -3164,10 +3156,10 @@
                 <a:solidFill>
                   <a:srgbClr val="FFFAEF"/>
                 </a:solidFill>
-                <a:latin typeface="Jua"/>
-                <a:ea typeface="Jua"/>
-                <a:cs typeface="Jua"/>
-                <a:sym typeface="Jua"/>
+                <a:latin typeface="무궁화 고딕"/>
+                <a:ea typeface="무궁화 고딕"/>
+                <a:cs typeface="무궁화 고딕"/>
+                <a:sym typeface="무궁화 고딕"/>
               </a:rPr>
               <a:t>바보 게임</a:t>
             </a:r>
@@ -3182,8 +3174,8 @@
         </p:nvSpPr>
         <p:spPr>
           <a:xfrm rot="0">
-            <a:off x="15264803" y="9812655"/>
-            <a:ext cx="2637975" cy="474345"/>
+            <a:off x="14703330" y="9822180"/>
+            <a:ext cx="3199449" cy="464820"/>
           </a:xfrm>
           <a:prstGeom prst="rect">
             <a:avLst/>
@@ -3208,10 +3200,10 @@
                 <a:solidFill>
                   <a:srgbClr val="FFFFFF"/>
                 </a:solidFill>
-                <a:latin typeface="TDTD갬성명조"/>
-                <a:ea typeface="TDTD갬성명조"/>
-                <a:cs typeface="TDTD갬성명조"/>
-                <a:sym typeface="TDTD갬성명조"/>
+                <a:latin typeface="무궁화 고딕"/>
+                <a:ea typeface="무궁화 고딕"/>
+                <a:cs typeface="무궁화 고딕"/>
+                <a:sym typeface="무궁화 고딕"/>
               </a:rPr>
               <a:t>ⓒ 2026. Sunday Play</a:t>
             </a:r>
@@ -3360,8 +3352,8 @@
         </p:nvSpPr>
         <p:spPr>
           <a:xfrm rot="0">
-            <a:off x="11392761" y="600705"/>
-            <a:ext cx="5362043" cy="1600200"/>
+            <a:off x="11392761" y="819780"/>
+            <a:ext cx="5362043" cy="1381125"/>
           </a:xfrm>
           <a:prstGeom prst="rect">
             <a:avLst/>
@@ -3383,10 +3375,10 @@
                 <a:solidFill>
                   <a:srgbClr val="FFFAEF"/>
                 </a:solidFill>
-                <a:latin typeface="Jua"/>
-                <a:ea typeface="Jua"/>
-                <a:cs typeface="Jua"/>
-                <a:sym typeface="Jua"/>
+                <a:latin typeface="무궁화 고딕"/>
+                <a:ea typeface="무궁화 고딕"/>
+                <a:cs typeface="무궁화 고딕"/>
+                <a:sym typeface="무궁화 고딕"/>
               </a:rPr>
               <a:t>규칙</a:t>
             </a:r>
@@ -3402,9 +3394,9 @@
         <p:grpSpPr>
           <a:xfrm rot="0">
             <a:off x="309172" y="535073"/>
-            <a:ext cx="12078314" cy="1779769"/>
+            <a:ext cx="12078314" cy="1702981"/>
             <a:chOff x="0" y="0"/>
-            <a:chExt cx="16104419" cy="2373026"/>
+            <a:chExt cx="16104419" cy="2270642"/>
           </a:xfrm>
         </p:grpSpPr>
         <p:sp>
@@ -3415,8 +3407,8 @@
           </p:nvSpPr>
           <p:spPr>
             <a:xfrm rot="0">
-              <a:off x="0" y="1380584"/>
-              <a:ext cx="16104419" cy="992442"/>
+              <a:off x="0" y="1390109"/>
+              <a:ext cx="16104419" cy="880533"/>
             </a:xfrm>
             <a:prstGeom prst="rect">
               <a:avLst/>
@@ -3430,30 +3422,30 @@
             <a:p>
               <a:pPr algn="l">
                 <a:lnSpc>
-                  <a:spcPts val="6273"/>
+                  <a:spcPts val="5599"/>
                 </a:lnSpc>
               </a:pPr>
               <a:r>
-                <a:rPr lang="en-US" sz="4480">
+                <a:rPr lang="en-US" sz="3999">
                   <a:solidFill>
                     <a:srgbClr val="FFFAEF"/>
                   </a:solidFill>
-                  <a:latin typeface="TDTD가온"/>
-                  <a:ea typeface="TDTD가온"/>
-                  <a:cs typeface="TDTD가온"/>
-                  <a:sym typeface="TDTD가온"/>
+                  <a:latin typeface="무궁화 고딕"/>
+                  <a:ea typeface="무궁화 고딕"/>
+                  <a:cs typeface="무궁화 고딕"/>
+                  <a:sym typeface="무궁화 고딕"/>
                 </a:rPr>
                 <a:t>원형으로 앉아 순서를</a:t>
               </a:r>
               <a:r>
-                <a:rPr lang="en-US" sz="4480">
+                <a:rPr lang="en-US" sz="3999">
                   <a:solidFill>
                     <a:srgbClr val="FFFAEF"/>
                   </a:solidFill>
-                  <a:latin typeface="TDTD가온"/>
-                  <a:ea typeface="TDTD가온"/>
-                  <a:cs typeface="TDTD가온"/>
-                  <a:sym typeface="TDTD가온"/>
+                  <a:latin typeface="무궁화 고딕"/>
+                  <a:ea typeface="무궁화 고딕"/>
+                  <a:cs typeface="무궁화 고딕"/>
+                  <a:sym typeface="무궁화 고딕"/>
                 </a:rPr>
                 <a:t> 정합니다.</a:t>
               </a:r>
@@ -3468,8 +3460,8 @@
           </p:nvSpPr>
           <p:spPr>
             <a:xfrm rot="0">
-              <a:off x="0" y="-171450"/>
-              <a:ext cx="9574913" cy="1169217"/>
+              <a:off x="0" y="-66675"/>
+              <a:ext cx="9574913" cy="1064442"/>
             </a:xfrm>
             <a:prstGeom prst="rect">
               <a:avLst/>
@@ -3491,10 +3483,10 @@
                   <a:solidFill>
                     <a:srgbClr val="FFFAEF"/>
                   </a:solidFill>
-                  <a:latin typeface="Jua"/>
-                  <a:ea typeface="Jua"/>
-                  <a:cs typeface="Jua"/>
-                  <a:sym typeface="Jua"/>
+                  <a:latin typeface="무궁화 고딕"/>
+                  <a:ea typeface="무궁화 고딕"/>
+                  <a:cs typeface="무궁화 고딕"/>
+                  <a:sym typeface="무궁화 고딕"/>
                 </a:rPr>
                 <a:t>STEP 1.</a:t>
               </a:r>
@@ -3511,9 +3503,9 @@
         <p:grpSpPr>
           <a:xfrm rot="0">
             <a:off x="12507852" y="7984396"/>
-            <a:ext cx="5385378" cy="1778769"/>
+            <a:ext cx="4751448" cy="1700694"/>
             <a:chOff x="0" y="0"/>
-            <a:chExt cx="7180505" cy="2371692"/>
+            <a:chExt cx="6335263" cy="2267592"/>
           </a:xfrm>
         </p:grpSpPr>
         <p:sp>
@@ -3525,7 +3517,7 @@
           <p:spPr>
             <a:xfrm rot="0">
               <a:off x="0" y="1377534"/>
-              <a:ext cx="7070728" cy="994158"/>
+              <a:ext cx="6238409" cy="890058"/>
             </a:xfrm>
             <a:prstGeom prst="rect">
               <a:avLst/>
@@ -3539,18 +3531,18 @@
             <a:p>
               <a:pPr algn="l">
                 <a:lnSpc>
-                  <a:spcPts val="6284"/>
+                  <a:spcPts val="5600"/>
                 </a:lnSpc>
               </a:pPr>
               <a:r>
-                <a:rPr lang="en-US" sz="4489">
+                <a:rPr lang="en-US" sz="4000">
                   <a:solidFill>
                     <a:srgbClr val="FFFAEF"/>
                   </a:solidFill>
-                  <a:latin typeface="TDTD가온"/>
-                  <a:ea typeface="TDTD가온"/>
-                  <a:cs typeface="TDTD가온"/>
-                  <a:sym typeface="TDTD가온"/>
+                  <a:latin typeface="무궁화 고딕"/>
+                  <a:ea typeface="무궁화 고딕"/>
+                  <a:cs typeface="무궁화 고딕"/>
+                  <a:sym typeface="무궁화 고딕"/>
                 </a:rPr>
                 <a:t>최후의 1인이 우승!</a:t>
               </a:r>
@@ -3565,8 +3557,8 @@
           </p:nvSpPr>
           <p:spPr>
             <a:xfrm rot="0">
-              <a:off x="0" y="-171450"/>
-              <a:ext cx="7180505" cy="1171105"/>
+              <a:off x="0" y="-57150"/>
+              <a:ext cx="6335263" cy="1056805"/>
             </a:xfrm>
             <a:prstGeom prst="rect">
               <a:avLst/>
@@ -3588,10 +3580,10 @@
                   <a:solidFill>
                     <a:srgbClr val="FFFAEF"/>
                   </a:solidFill>
-                  <a:latin typeface="Jua"/>
-                  <a:ea typeface="Jua"/>
-                  <a:cs typeface="Jua"/>
-                  <a:sym typeface="Jua"/>
+                  <a:latin typeface="무궁화 고딕"/>
+                  <a:ea typeface="무궁화 고딕"/>
+                  <a:cs typeface="무궁화 고딕"/>
+                  <a:sym typeface="무궁화 고딕"/>
                 </a:rPr>
                 <a:t>STEP 3.</a:t>
               </a:r>
@@ -3607,10 +3599,10 @@
         </p:nvGrpSpPr>
         <p:grpSpPr>
           <a:xfrm rot="0">
-            <a:off x="3834896" y="3864595"/>
-            <a:ext cx="11500525" cy="2570047"/>
+            <a:off x="3694527" y="3909321"/>
+            <a:ext cx="11781262" cy="2403807"/>
             <a:chOff x="0" y="0"/>
-            <a:chExt cx="15334033" cy="3426730"/>
+            <a:chExt cx="15708349" cy="3205076"/>
           </a:xfrm>
         </p:grpSpPr>
         <p:sp>
@@ -3621,8 +3613,8 @@
           </p:nvSpPr>
           <p:spPr>
             <a:xfrm rot="0">
-              <a:off x="0" y="1375218"/>
-              <a:ext cx="15334033" cy="2051512"/>
+              <a:off x="0" y="1384743"/>
+              <a:ext cx="15708349" cy="1820333"/>
             </a:xfrm>
             <a:prstGeom prst="rect">
               <a:avLst/>
@@ -3636,18 +3628,18 @@
             <a:p>
               <a:pPr algn="l">
                 <a:lnSpc>
-                  <a:spcPts val="6275"/>
+                  <a:spcPts val="5599"/>
                 </a:lnSpc>
               </a:pPr>
               <a:r>
-                <a:rPr lang="en-US" sz="4482">
+                <a:rPr lang="en-US" sz="3999">
                   <a:solidFill>
                     <a:srgbClr val="FFFAEF"/>
                   </a:solidFill>
-                  <a:latin typeface="TDTD가온"/>
-                  <a:ea typeface="TDTD가온"/>
-                  <a:cs typeface="TDTD가온"/>
-                  <a:sym typeface="TDTD가온"/>
+                  <a:latin typeface="무궁화 고딕"/>
+                  <a:ea typeface="무궁화 고딕"/>
+                  <a:cs typeface="무궁화 고딕"/>
+                  <a:sym typeface="무궁화 고딕"/>
                 </a:rPr>
                 <a:t>1초 안에 숫자를 외치면서 손가락은 다른 숫자를 펼치세요!</a:t>
               </a:r>
@@ -3655,18 +3647,18 @@
             <a:p>
               <a:pPr algn="l">
                 <a:lnSpc>
-                  <a:spcPts val="6275"/>
+                  <a:spcPts val="5599"/>
                 </a:lnSpc>
               </a:pPr>
               <a:r>
-                <a:rPr lang="en-US" sz="4482">
+                <a:rPr lang="en-US" sz="3999">
                   <a:solidFill>
                     <a:srgbClr val="FFFAEF"/>
                   </a:solidFill>
-                  <a:latin typeface="TDTD가온"/>
-                  <a:ea typeface="TDTD가온"/>
-                  <a:cs typeface="TDTD가온"/>
-                  <a:sym typeface="TDTD가온"/>
+                  <a:latin typeface="무궁화 고딕"/>
+                  <a:ea typeface="무궁화 고딕"/>
+                  <a:cs typeface="무궁화 고딕"/>
+                  <a:sym typeface="무궁화 고딕"/>
                 </a:rPr>
                 <a:t>입과 손이 같으면 탈락! 앞 사람과 같은 숫자 금지! </a:t>
               </a:r>
@@ -3681,8 +3673,8 @@
           </p:nvSpPr>
           <p:spPr>
             <a:xfrm rot="0">
-              <a:off x="0" y="-171450"/>
-              <a:ext cx="6898637" cy="1169523"/>
+              <a:off x="0" y="-57150"/>
+              <a:ext cx="7067038" cy="1055223"/>
             </a:xfrm>
             <a:prstGeom prst="rect">
               <a:avLst/>
@@ -3704,10 +3696,10 @@
                   <a:solidFill>
                     <a:srgbClr val="FFFAEF"/>
                   </a:solidFill>
-                  <a:latin typeface="Jua"/>
-                  <a:ea typeface="Jua"/>
-                  <a:cs typeface="Jua"/>
-                  <a:sym typeface="Jua"/>
+                  <a:latin typeface="무궁화 고딕"/>
+                  <a:ea typeface="무궁화 고딕"/>
+                  <a:cs typeface="무궁화 고딕"/>
+                  <a:sym typeface="무궁화 고딕"/>
                 </a:rPr>
                 <a:t>STEP 2.</a:t>
               </a:r>
@@ -3805,8 +3797,8 @@
         </p:nvSpPr>
         <p:spPr>
           <a:xfrm rot="0">
-            <a:off x="1028700" y="3892867"/>
-            <a:ext cx="15555091" cy="2200275"/>
+            <a:off x="1028700" y="4178617"/>
+            <a:ext cx="15555091" cy="1914525"/>
           </a:xfrm>
           <a:prstGeom prst="rect">
             <a:avLst/>
@@ -3828,10 +3820,10 @@
                 <a:solidFill>
                   <a:srgbClr val="FFFAEF"/>
                 </a:solidFill>
-                <a:latin typeface="Jua"/>
-                <a:ea typeface="Jua"/>
-                <a:cs typeface="Jua"/>
-                <a:sym typeface="Jua"/>
+                <a:latin typeface="무궁화 고딕"/>
+                <a:ea typeface="무궁화 고딕"/>
+                <a:cs typeface="무궁화 고딕"/>
+                <a:sym typeface="무궁화 고딕"/>
               </a:rPr>
               <a:t>바보 게임</a:t>
             </a:r>
@@ -3846,8 +3838,8 @@
         </p:nvSpPr>
         <p:spPr>
           <a:xfrm rot="0">
-            <a:off x="15264803" y="9812655"/>
-            <a:ext cx="2637975" cy="474345"/>
+            <a:off x="14703330" y="9822180"/>
+            <a:ext cx="3199449" cy="464820"/>
           </a:xfrm>
           <a:prstGeom prst="rect">
             <a:avLst/>
@@ -3872,10 +3864,10 @@
                 <a:solidFill>
                   <a:srgbClr val="FFFFFF"/>
                 </a:solidFill>
-                <a:latin typeface="TDTD갬성명조"/>
-                <a:ea typeface="TDTD갬성명조"/>
-                <a:cs typeface="TDTD갬성명조"/>
-                <a:sym typeface="TDTD갬성명조"/>
+                <a:latin typeface="무궁화 고딕"/>
+                <a:ea typeface="무궁화 고딕"/>
+                <a:cs typeface="무궁화 고딕"/>
+                <a:sym typeface="무궁화 고딕"/>
               </a:rPr>
               <a:t>ⓒ 2026. Sunday Play</a:t>
             </a:r>
@@ -3947,8 +3939,8 @@
         </p:nvSpPr>
         <p:spPr>
           <a:xfrm rot="0">
-            <a:off x="4421807" y="3895725"/>
-            <a:ext cx="9444385" cy="2200275"/>
+            <a:off x="4421807" y="4181475"/>
+            <a:ext cx="9444385" cy="1914525"/>
           </a:xfrm>
           <a:prstGeom prst="rect">
             <a:avLst/>
@@ -3970,10 +3962,10 @@
                 <a:solidFill>
                   <a:srgbClr val="000000"/>
                 </a:solidFill>
-                <a:latin typeface="Jua"/>
-                <a:ea typeface="Jua"/>
-                <a:cs typeface="Jua"/>
-                <a:sym typeface="Jua"/>
+                <a:latin typeface="무궁화 고딕"/>
+                <a:ea typeface="무궁화 고딕"/>
+                <a:cs typeface="무궁화 고딕"/>
+                <a:sym typeface="무궁화 고딕"/>
               </a:rPr>
               <a:t>감사합니다!</a:t>
             </a:r>

</xml_diff>